<commit_message>
docs: split architecture diagram; map slide uses the parts view
</commit_message>
<xml_diff>
--- a/docs/slides/aiInvesting-slides.pptx
+++ b/docs/slides/aiInvesting-slides.pptx
@@ -24824,7 +24824,7 @@
                 </a:solidFill>
                 <a:latin typeface="Aptos"/>
               </a:rPr>
-              <a:t>Rendered from docs/architecture.html in the repo. The same diagram is in docs/ARCHITECTURE.md with the season flow, the agent table and the on-disk layout.</a:t>
+              <a:t>docs/architecture.png in the repo, drawn by docs/draw_architecture.py. docs/ARCHITECTURE.md adds the agent table, the on-disk layout and where to change things.</a:t>
             </a:r>
           </a:p>
         </p:txBody>
@@ -24837,8 +24837,8 @@
         </p:nvSpPr>
         <p:spPr>
           <a:xfrm>
-            <a:off x="3040621" y="969264"/>
-            <a:ext cx="6107709" cy="5513832"/>
+            <a:off x="2106385" y="923544"/>
+            <a:ext cx="7976180" cy="5605271"/>
           </a:xfrm>
           <a:prstGeom prst="roundRect">
             <a:avLst>
@@ -24879,7 +24879,7 @@
       </p:sp>
       <p:pic>
         <p:nvPicPr>
-          <p:cNvPr id="8" name="Picture 7" descr="architecture.png"/>
+          <p:cNvPr id="8" name="Picture 7" descr="architecture_parts.png"/>
           <p:cNvPicPr>
             <a:picLocks noChangeAspect="1"/>
           </p:cNvPicPr>
@@ -24893,8 +24893,8 @@
         </p:blipFill>
         <p:spPr>
           <a:xfrm>
-            <a:off x="3077197" y="1005840"/>
-            <a:ext cx="6034557" cy="5440680"/>
+            <a:off x="2142961" y="960120"/>
+            <a:ext cx="7903028" cy="5532119"/>
           </a:xfrm>
           <a:prstGeom prst="rect">
             <a:avLst/>

</xml_diff>